<commit_message>
Tweaks in pptx template and functions have been tested
</commit_message>
<xml_diff>
--- a/template.pptx
+++ b/template.pptx
@@ -2,19 +2,19 @@
 <file path=ppt/presentation.xml><?xml version="1.0" encoding="utf-8"?>
 <p:presentation xmlns:a="http://schemas.openxmlformats.org/drawingml/2006/main" xmlns:r="http://schemas.openxmlformats.org/officeDocument/2006/relationships" xmlns:p="http://schemas.openxmlformats.org/presentationml/2006/main" saveSubsetFonts="1" autoCompressPictures="0">
   <p:sldMasterIdLst>
-    <p:sldMasterId id="2147483648" r:id="rId1"/>
+    <p:sldMasterId id="2147483648" r:id="rId3"/>
   </p:sldMasterIdLst>
   <p:notesMasterIdLst>
-    <p:notesMasterId r:id="rId6"/>
+    <p:notesMasterId r:id="rId8"/>
   </p:notesMasterIdLst>
   <p:handoutMasterIdLst>
-    <p:handoutMasterId r:id="rId7"/>
+    <p:handoutMasterId r:id="rId9"/>
   </p:handoutMasterIdLst>
   <p:sldIdLst>
-    <p:sldId id="256" r:id="rId2"/>
-    <p:sldId id="257" r:id="rId3"/>
-    <p:sldId id="258" r:id="rId4"/>
-    <p:sldId id="259" r:id="rId5"/>
+    <p:sldId id="256" r:id="rId4"/>
+    <p:sldId id="257" r:id="rId5"/>
+    <p:sldId id="258" r:id="rId6"/>
+    <p:sldId id="259" r:id="rId7"/>
   </p:sldIdLst>
   <p:sldSz cx="9144000" cy="5143500" type="screen16x9"/>
   <p:notesSz cx="6858000" cy="9144000"/>
@@ -146,44 +146,45 @@
 <file path=ppt/changesInfos/changesInfo1.xml><?xml version="1.0" encoding="utf-8"?>
 <pc:chgInfo xmlns:a="http://schemas.openxmlformats.org/drawingml/2006/main" xmlns:r="http://schemas.openxmlformats.org/officeDocument/2006/relationships" xmlns:ac="http://schemas.microsoft.com/office/drawing/2013/main/command" xmlns:pc="http://schemas.microsoft.com/office/powerpoint/2013/main/command">
   <pc:docChgLst>
-    <pc:chgData name="KEANE, Ruth (NHS ARDEN AND GREATER EAST MIDLANDS COMMISSIONING SUPPORT UNIT)" userId="864e1a6a-91f5-4fd3-93f1-22e6b2664edd" providerId="ADAL" clId="{EB48CAD1-69F9-4960-AA93-D3AFEC0F4A94}"/>
+    <pc:chgData name="KEANE, Ruth (NHS ARDEN AND GREATER EAST MIDLANDS COMMISSIONING SUPPORT UNIT)" userId="864e1a6a-91f5-4fd3-93f1-22e6b2664edd" providerId="ADAL" clId="{1863A29F-A97B-4B6D-9724-B05817A64C12}"/>
     <pc:docChg chg="undo custSel modMainMaster">
-      <pc:chgData name="KEANE, Ruth (NHS ARDEN AND GREATER EAST MIDLANDS COMMISSIONING SUPPORT UNIT)" userId="864e1a6a-91f5-4fd3-93f1-22e6b2664edd" providerId="ADAL" clId="{EB48CAD1-69F9-4960-AA93-D3AFEC0F4A94}" dt="2024-06-27T13:08:09.411" v="3" actId="1076"/>
+      <pc:chgData name="KEANE, Ruth (NHS ARDEN AND GREATER EAST MIDLANDS COMMISSIONING SUPPORT UNIT)" userId="864e1a6a-91f5-4fd3-93f1-22e6b2664edd" providerId="ADAL" clId="{1863A29F-A97B-4B6D-9724-B05817A64C12}" dt="2024-06-04T10:22:49.388" v="24" actId="14100"/>
       <pc:docMkLst>
         <pc:docMk/>
       </pc:docMkLst>
       <pc:sldMasterChg chg="modSldLayout">
-        <pc:chgData name="KEANE, Ruth (NHS ARDEN AND GREATER EAST MIDLANDS COMMISSIONING SUPPORT UNIT)" userId="864e1a6a-91f5-4fd3-93f1-22e6b2664edd" providerId="ADAL" clId="{EB48CAD1-69F9-4960-AA93-D3AFEC0F4A94}" dt="2024-06-27T13:08:09.411" v="3" actId="1076"/>
+        <pc:chgData name="KEANE, Ruth (NHS ARDEN AND GREATER EAST MIDLANDS COMMISSIONING SUPPORT UNIT)" userId="864e1a6a-91f5-4fd3-93f1-22e6b2664edd" providerId="ADAL" clId="{1863A29F-A97B-4B6D-9724-B05817A64C12}" dt="2024-06-04T10:22:49.388" v="24" actId="14100"/>
         <pc:sldMasterMkLst>
           <pc:docMk/>
           <pc:sldMasterMk cId="3676200875" sldId="2147483648"/>
         </pc:sldMasterMkLst>
         <pc:sldLayoutChg chg="modSp mod">
-          <pc:chgData name="KEANE, Ruth (NHS ARDEN AND GREATER EAST MIDLANDS COMMISSIONING SUPPORT UNIT)" userId="864e1a6a-91f5-4fd3-93f1-22e6b2664edd" providerId="ADAL" clId="{EB48CAD1-69F9-4960-AA93-D3AFEC0F4A94}" dt="2024-06-20T13:10:24.295" v="1" actId="14100"/>
-          <pc:sldLayoutMkLst>
-            <pc:docMk/>
-            <pc:sldMasterMk cId="3676200875" sldId="2147483648"/>
-            <pc:sldLayoutMk cId="338346009" sldId="2147483650"/>
-          </pc:sldLayoutMkLst>
-          <pc:spChg chg="mod">
-            <ac:chgData name="KEANE, Ruth (NHS ARDEN AND GREATER EAST MIDLANDS COMMISSIONING SUPPORT UNIT)" userId="864e1a6a-91f5-4fd3-93f1-22e6b2664edd" providerId="ADAL" clId="{EB48CAD1-69F9-4960-AA93-D3AFEC0F4A94}" dt="2024-06-20T13:10:24.295" v="1" actId="14100"/>
-            <ac:spMkLst>
-              <pc:docMk/>
-              <pc:sldMasterMk cId="3676200875" sldId="2147483648"/>
-              <pc:sldLayoutMk cId="338346009" sldId="2147483650"/>
-              <ac:spMk id="3" creationId="{00000000-0000-0000-0000-000000000000}"/>
-            </ac:spMkLst>
-          </pc:spChg>
-        </pc:sldLayoutChg>
-        <pc:sldLayoutChg chg="modSp mod">
-          <pc:chgData name="KEANE, Ruth (NHS ARDEN AND GREATER EAST MIDLANDS COMMISSIONING SUPPORT UNIT)" userId="864e1a6a-91f5-4fd3-93f1-22e6b2664edd" providerId="ADAL" clId="{EB48CAD1-69F9-4960-AA93-D3AFEC0F4A94}" dt="2024-06-27T13:08:09.411" v="3" actId="1076"/>
+          <pc:chgData name="KEANE, Ruth (NHS ARDEN AND GREATER EAST MIDLANDS COMMISSIONING SUPPORT UNIT)" userId="864e1a6a-91f5-4fd3-93f1-22e6b2664edd" providerId="ADAL" clId="{1863A29F-A97B-4B6D-9724-B05817A64C12}" dt="2024-06-04T10:22:49.388" v="24" actId="14100"/>
           <pc:sldLayoutMkLst>
             <pc:docMk/>
             <pc:sldMasterMk cId="3676200875" sldId="2147483648"/>
             <pc:sldLayoutMk cId="2619886245" sldId="2147483652"/>
           </pc:sldLayoutMkLst>
           <pc:spChg chg="mod">
-            <ac:chgData name="KEANE, Ruth (NHS ARDEN AND GREATER EAST MIDLANDS COMMISSIONING SUPPORT UNIT)" userId="864e1a6a-91f5-4fd3-93f1-22e6b2664edd" providerId="ADAL" clId="{EB48CAD1-69F9-4960-AA93-D3AFEC0F4A94}" dt="2024-06-27T13:08:09.411" v="3" actId="1076"/>
+            <ac:chgData name="KEANE, Ruth (NHS ARDEN AND GREATER EAST MIDLANDS COMMISSIONING SUPPORT UNIT)" userId="864e1a6a-91f5-4fd3-93f1-22e6b2664edd" providerId="ADAL" clId="{1863A29F-A97B-4B6D-9724-B05817A64C12}" dt="2024-05-20T17:13:33.358" v="14" actId="14100"/>
+            <ac:spMkLst>
+              <pc:docMk/>
+              <pc:sldMasterMk cId="3676200875" sldId="2147483648"/>
+              <pc:sldLayoutMk cId="2619886245" sldId="2147483652"/>
+              <ac:spMk id="2" creationId="{00000000-0000-0000-0000-000000000000}"/>
+            </ac:spMkLst>
+          </pc:spChg>
+          <pc:spChg chg="mod">
+            <ac:chgData name="KEANE, Ruth (NHS ARDEN AND GREATER EAST MIDLANDS COMMISSIONING SUPPORT UNIT)" userId="864e1a6a-91f5-4fd3-93f1-22e6b2664edd" providerId="ADAL" clId="{1863A29F-A97B-4B6D-9724-B05817A64C12}" dt="2024-06-04T10:22:49.388" v="24" actId="14100"/>
+            <ac:spMkLst>
+              <pc:docMk/>
+              <pc:sldMasterMk cId="3676200875" sldId="2147483648"/>
+              <pc:sldLayoutMk cId="2619886245" sldId="2147483652"/>
+              <ac:spMk id="3" creationId="{00000000-0000-0000-0000-000000000000}"/>
+            </ac:spMkLst>
+          </pc:spChg>
+          <pc:spChg chg="mod">
+            <ac:chgData name="KEANE, Ruth (NHS ARDEN AND GREATER EAST MIDLANDS COMMISSIONING SUPPORT UNIT)" userId="864e1a6a-91f5-4fd3-93f1-22e6b2664edd" providerId="ADAL" clId="{1863A29F-A97B-4B6D-9724-B05817A64C12}" dt="2024-06-04T10:22:46.448" v="23" actId="14100"/>
             <ac:spMkLst>
               <pc:docMk/>
               <pc:sldMasterMk cId="3676200875" sldId="2147483648"/>
@@ -700,45 +701,44 @@
     </pc:docChg>
   </pc:docChgLst>
   <pc:docChgLst>
-    <pc:chgData name="KEANE, Ruth (NHS ARDEN AND GREATER EAST MIDLANDS COMMISSIONING SUPPORT UNIT)" userId="864e1a6a-91f5-4fd3-93f1-22e6b2664edd" providerId="ADAL" clId="{1863A29F-A97B-4B6D-9724-B05817A64C12}"/>
+    <pc:chgData name="KEANE, Ruth (NHS ARDEN AND GREATER EAST MIDLANDS COMMISSIONING SUPPORT UNIT)" userId="864e1a6a-91f5-4fd3-93f1-22e6b2664edd" providerId="ADAL" clId="{EB48CAD1-69F9-4960-AA93-D3AFEC0F4A94}"/>
     <pc:docChg chg="undo custSel modMainMaster">
-      <pc:chgData name="KEANE, Ruth (NHS ARDEN AND GREATER EAST MIDLANDS COMMISSIONING SUPPORT UNIT)" userId="864e1a6a-91f5-4fd3-93f1-22e6b2664edd" providerId="ADAL" clId="{1863A29F-A97B-4B6D-9724-B05817A64C12}" dt="2024-06-04T10:22:49.388" v="24" actId="14100"/>
+      <pc:chgData name="KEANE, Ruth (NHS ARDEN AND GREATER EAST MIDLANDS COMMISSIONING SUPPORT UNIT)" userId="864e1a6a-91f5-4fd3-93f1-22e6b2664edd" providerId="ADAL" clId="{EB48CAD1-69F9-4960-AA93-D3AFEC0F4A94}" dt="2024-06-27T13:08:09.411" v="3" actId="1076"/>
       <pc:docMkLst>
         <pc:docMk/>
       </pc:docMkLst>
       <pc:sldMasterChg chg="modSldLayout">
-        <pc:chgData name="KEANE, Ruth (NHS ARDEN AND GREATER EAST MIDLANDS COMMISSIONING SUPPORT UNIT)" userId="864e1a6a-91f5-4fd3-93f1-22e6b2664edd" providerId="ADAL" clId="{1863A29F-A97B-4B6D-9724-B05817A64C12}" dt="2024-06-04T10:22:49.388" v="24" actId="14100"/>
+        <pc:chgData name="KEANE, Ruth (NHS ARDEN AND GREATER EAST MIDLANDS COMMISSIONING SUPPORT UNIT)" userId="864e1a6a-91f5-4fd3-93f1-22e6b2664edd" providerId="ADAL" clId="{EB48CAD1-69F9-4960-AA93-D3AFEC0F4A94}" dt="2024-06-27T13:08:09.411" v="3" actId="1076"/>
         <pc:sldMasterMkLst>
           <pc:docMk/>
           <pc:sldMasterMk cId="3676200875" sldId="2147483648"/>
         </pc:sldMasterMkLst>
         <pc:sldLayoutChg chg="modSp mod">
-          <pc:chgData name="KEANE, Ruth (NHS ARDEN AND GREATER EAST MIDLANDS COMMISSIONING SUPPORT UNIT)" userId="864e1a6a-91f5-4fd3-93f1-22e6b2664edd" providerId="ADAL" clId="{1863A29F-A97B-4B6D-9724-B05817A64C12}" dt="2024-06-04T10:22:49.388" v="24" actId="14100"/>
+          <pc:chgData name="KEANE, Ruth (NHS ARDEN AND GREATER EAST MIDLANDS COMMISSIONING SUPPORT UNIT)" userId="864e1a6a-91f5-4fd3-93f1-22e6b2664edd" providerId="ADAL" clId="{EB48CAD1-69F9-4960-AA93-D3AFEC0F4A94}" dt="2024-06-20T13:10:24.295" v="1" actId="14100"/>
+          <pc:sldLayoutMkLst>
+            <pc:docMk/>
+            <pc:sldMasterMk cId="3676200875" sldId="2147483648"/>
+            <pc:sldLayoutMk cId="338346009" sldId="2147483650"/>
+          </pc:sldLayoutMkLst>
+          <pc:spChg chg="mod">
+            <ac:chgData name="KEANE, Ruth (NHS ARDEN AND GREATER EAST MIDLANDS COMMISSIONING SUPPORT UNIT)" userId="864e1a6a-91f5-4fd3-93f1-22e6b2664edd" providerId="ADAL" clId="{EB48CAD1-69F9-4960-AA93-D3AFEC0F4A94}" dt="2024-06-20T13:10:24.295" v="1" actId="14100"/>
+            <ac:spMkLst>
+              <pc:docMk/>
+              <pc:sldMasterMk cId="3676200875" sldId="2147483648"/>
+              <pc:sldLayoutMk cId="338346009" sldId="2147483650"/>
+              <ac:spMk id="3" creationId="{00000000-0000-0000-0000-000000000000}"/>
+            </ac:spMkLst>
+          </pc:spChg>
+        </pc:sldLayoutChg>
+        <pc:sldLayoutChg chg="modSp mod">
+          <pc:chgData name="KEANE, Ruth (NHS ARDEN AND GREATER EAST MIDLANDS COMMISSIONING SUPPORT UNIT)" userId="864e1a6a-91f5-4fd3-93f1-22e6b2664edd" providerId="ADAL" clId="{EB48CAD1-69F9-4960-AA93-D3AFEC0F4A94}" dt="2024-06-27T13:08:09.411" v="3" actId="1076"/>
           <pc:sldLayoutMkLst>
             <pc:docMk/>
             <pc:sldMasterMk cId="3676200875" sldId="2147483648"/>
             <pc:sldLayoutMk cId="2619886245" sldId="2147483652"/>
           </pc:sldLayoutMkLst>
           <pc:spChg chg="mod">
-            <ac:chgData name="KEANE, Ruth (NHS ARDEN AND GREATER EAST MIDLANDS COMMISSIONING SUPPORT UNIT)" userId="864e1a6a-91f5-4fd3-93f1-22e6b2664edd" providerId="ADAL" clId="{1863A29F-A97B-4B6D-9724-B05817A64C12}" dt="2024-05-20T17:13:33.358" v="14" actId="14100"/>
-            <ac:spMkLst>
-              <pc:docMk/>
-              <pc:sldMasterMk cId="3676200875" sldId="2147483648"/>
-              <pc:sldLayoutMk cId="2619886245" sldId="2147483652"/>
-              <ac:spMk id="2" creationId="{00000000-0000-0000-0000-000000000000}"/>
-            </ac:spMkLst>
-          </pc:spChg>
-          <pc:spChg chg="mod">
-            <ac:chgData name="KEANE, Ruth (NHS ARDEN AND GREATER EAST MIDLANDS COMMISSIONING SUPPORT UNIT)" userId="864e1a6a-91f5-4fd3-93f1-22e6b2664edd" providerId="ADAL" clId="{1863A29F-A97B-4B6D-9724-B05817A64C12}" dt="2024-06-04T10:22:49.388" v="24" actId="14100"/>
-            <ac:spMkLst>
-              <pc:docMk/>
-              <pc:sldMasterMk cId="3676200875" sldId="2147483648"/>
-              <pc:sldLayoutMk cId="2619886245" sldId="2147483652"/>
-              <ac:spMk id="3" creationId="{00000000-0000-0000-0000-000000000000}"/>
-            </ac:spMkLst>
-          </pc:spChg>
-          <pc:spChg chg="mod">
-            <ac:chgData name="KEANE, Ruth (NHS ARDEN AND GREATER EAST MIDLANDS COMMISSIONING SUPPORT UNIT)" userId="864e1a6a-91f5-4fd3-93f1-22e6b2664edd" providerId="ADAL" clId="{1863A29F-A97B-4B6D-9724-B05817A64C12}" dt="2024-06-04T10:22:46.448" v="23" actId="14100"/>
+            <ac:chgData name="KEANE, Ruth (NHS ARDEN AND GREATER EAST MIDLANDS COMMISSIONING SUPPORT UNIT)" userId="864e1a6a-91f5-4fd3-93f1-22e6b2664edd" providerId="ADAL" clId="{EB48CAD1-69F9-4960-AA93-D3AFEC0F4A94}" dt="2024-06-27T13:08:09.411" v="3" actId="1076"/>
             <ac:spMkLst>
               <pc:docMk/>
               <pc:sldMasterMk cId="3676200875" sldId="2147483648"/>
@@ -847,7 +847,7 @@
           <a:p>
             <a:fld id="{B48A1614-D8D7-475C-80BF-391585C94D4C}" type="datetimeFigureOut">
               <a:rPr lang="en-GB" smtClean="0"/>
-              <a:t>27/06/2024</a:t>
+              <a:t>31/10/2024</a:t>
             </a:fld>
             <a:endParaRPr lang="en-GB"/>
           </a:p>
@@ -1024,7 +1024,7 @@
           <a:p>
             <a:fld id="{0F9C1CCF-B725-44A7-AA57-5E433BD85C9F}" type="datetimeFigureOut">
               <a:rPr lang="en-US" smtClean="0"/>
-              <a:t>6/27/2024</a:t>
+              <a:t>10/31/2024</a:t>
             </a:fld>
             <a:endParaRPr lang="en-US"/>
           </a:p>
@@ -1783,7 +1783,7 @@
             <a:fld id="{241EB5C9-1307-BA42-ABA2-0BC069CD8E7F}" type="datetimeFigureOut">
               <a:rPr lang="en-US" smtClean="0"/>
               <a:pPr/>
-              <a:t>6/27/2024</a:t>
+              <a:t>10/31/2024</a:t>
             </a:fld>
             <a:endParaRPr lang="en-US"/>
           </a:p>
@@ -1996,7 +1996,7 @@
           <a:p>
             <a:fld id="{241EB5C9-1307-BA42-ABA2-0BC069CD8E7F}" type="datetimeFigureOut">
               <a:rPr lang="en-US" smtClean="0"/>
-              <a:t>6/27/2024</a:t>
+              <a:t>10/31/2024</a:t>
             </a:fld>
             <a:endParaRPr lang="en-US"/>
           </a:p>
@@ -2247,7 +2247,7 @@
           <a:p>
             <a:fld id="{241EB5C9-1307-BA42-ABA2-0BC069CD8E7F}" type="datetimeFigureOut">
               <a:rPr lang="en-US" smtClean="0"/>
-              <a:t>6/27/2024</a:t>
+              <a:t>10/31/2024</a:t>
             </a:fld>
             <a:endParaRPr lang="en-US"/>
           </a:p>
@@ -2648,61 +2648,36 @@
           <a:chExt cx="0" cy="0"/>
         </a:xfrm>
       </p:grpSpPr>
-      <p:sp>
-        <p:nvSpPr>
-          <p:cNvPr id="7" name="Rectangle 6">
+      <p:pic>
+        <p:nvPicPr>
+          <p:cNvPr id="9" name="Picture 8" descr="Icon&#10;&#10;Description automatically generated">
             <a:extLst>
               <a:ext uri="{FF2B5EF4-FFF2-40B4-BE49-F238E27FC236}">
-                <a16:creationId xmlns:a16="http://schemas.microsoft.com/office/drawing/2014/main" id="{26723C22-B06C-B8C6-3C6F-70C9A069DC5A}"/>
+                <a16:creationId xmlns:a16="http://schemas.microsoft.com/office/drawing/2014/main" id="{DE783C50-9B77-EA8A-2629-125991C9F05E}"/>
               </a:ext>
             </a:extLst>
           </p:cNvPr>
-          <p:cNvSpPr/>
+          <p:cNvPicPr>
+            <a:picLocks noChangeAspect="1"/>
+          </p:cNvPicPr>
           <p:nvPr userDrawn="1"/>
-        </p:nvSpPr>
+        </p:nvPicPr>
+        <p:blipFill>
+          <a:blip r:embed="rId2"/>
+          <a:stretch>
+            <a:fillRect/>
+          </a:stretch>
+        </p:blipFill>
         <p:spPr>
           <a:xfrm>
-            <a:off x="0" y="1"/>
-            <a:ext cx="9144000" cy="5143499"/>
+            <a:off x="0" y="0"/>
+            <a:ext cx="9144000" cy="5143500"/>
           </a:xfrm>
           <a:prstGeom prst="rect">
             <a:avLst/>
           </a:prstGeom>
-          <a:solidFill>
-            <a:srgbClr val="F6F8F8"/>
-          </a:solidFill>
-          <a:ln>
-            <a:noFill/>
-          </a:ln>
         </p:spPr>
-        <p:style>
-          <a:lnRef idx="2">
-            <a:schemeClr val="accent1">
-              <a:shade val="50000"/>
-            </a:schemeClr>
-          </a:lnRef>
-          <a:fillRef idx="1">
-            <a:schemeClr val="accent1"/>
-          </a:fillRef>
-          <a:effectRef idx="0">
-            <a:schemeClr val="accent1"/>
-          </a:effectRef>
-          <a:fontRef idx="minor">
-            <a:schemeClr val="lt1"/>
-          </a:fontRef>
-        </p:style>
-        <p:txBody>
-          <a:bodyPr rtlCol="0" anchor="ctr"/>
-          <a:lstStyle/>
-          <a:p>
-            <a:pPr algn="ctr"/>
-            <a:endParaRPr lang="en-GB">
-              <a:latin typeface="Arial" panose="020B0604020202020204" pitchFamily="34" charset="0"/>
-              <a:cs typeface="Arial" panose="020B0604020202020204" pitchFamily="34" charset="0"/>
-            </a:endParaRPr>
-          </a:p>
-        </p:txBody>
-      </p:sp>
+      </p:pic>
       <p:sp>
         <p:nvSpPr>
           <p:cNvPr id="2" name="Title 1"/>
@@ -2870,7 +2845,7 @@
           <a:p>
             <a:fld id="{241EB5C9-1307-BA42-ABA2-0BC069CD8E7F}" type="datetimeFigureOut">
               <a:rPr lang="en-US" smtClean="0"/>
-              <a:t>6/27/2024</a:t>
+              <a:t>10/31/2024</a:t>
             </a:fld>
             <a:endParaRPr lang="en-US"/>
           </a:p>
@@ -3601,7 +3576,7 @@
           <a:p>
             <a:fld id="{241EB5C9-1307-BA42-ABA2-0BC069CD8E7F}" type="datetimeFigureOut">
               <a:rPr lang="en-US" smtClean="0"/>
-              <a:t>6/27/2024</a:t>
+              <a:t>10/31/2024</a:t>
             </a:fld>
             <a:endParaRPr lang="en-US"/>
           </a:p>
@@ -3791,7 +3766,7 @@
           <a:p>
             <a:fld id="{241EB5C9-1307-BA42-ABA2-0BC069CD8E7F}" type="datetimeFigureOut">
               <a:rPr lang="en-US" smtClean="0"/>
-              <a:t>6/27/2024</a:t>
+              <a:t>10/31/2024</a:t>
             </a:fld>
             <a:endParaRPr lang="en-US"/>
           </a:p>
@@ -3959,7 +3934,7 @@
           <a:p>
             <a:fld id="{241EB5C9-1307-BA42-ABA2-0BC069CD8E7F}" type="datetimeFigureOut">
               <a:rPr lang="en-US" smtClean="0"/>
-              <a:t>6/27/2024</a:t>
+              <a:t>10/31/2024</a:t>
             </a:fld>
             <a:endParaRPr lang="en-US"/>
           </a:p>
@@ -4307,7 +4282,7 @@
           <a:p>
             <a:fld id="{241EB5C9-1307-BA42-ABA2-0BC069CD8E7F}" type="datetimeFigureOut">
               <a:rPr lang="en-US" smtClean="0"/>
-              <a:t>6/27/2024</a:t>
+              <a:t>10/31/2024</a:t>
             </a:fld>
             <a:endParaRPr lang="en-US"/>
           </a:p>
@@ -4632,7 +4607,7 @@
           <a:p>
             <a:fld id="{241EB5C9-1307-BA42-ABA2-0BC069CD8E7F}" type="datetimeFigureOut">
               <a:rPr lang="en-US" smtClean="0"/>
-              <a:t>6/27/2024</a:t>
+              <a:t>10/31/2024</a:t>
             </a:fld>
             <a:endParaRPr lang="en-US"/>
           </a:p>
@@ -4919,7 +4894,7 @@
             <a:fld id="{241EB5C9-1307-BA42-ABA2-0BC069CD8E7F}" type="datetimeFigureOut">
               <a:rPr lang="en-US" smtClean="0"/>
               <a:pPr/>
-              <a:t>6/27/2024</a:t>
+              <a:t>10/31/2024</a:t>
             </a:fld>
             <a:endParaRPr lang="en-US"/>
           </a:p>
@@ -5492,6 +5467,13 @@
           </p:nvPr>
         </p:nvSpPr>
         <p:spPr/>
+        <p:txBody>
+          <a:bodyPr/>
+          <a:lstStyle/>
+          <a:p>
+            <a:endParaRPr lang="en-GB"/>
+          </a:p>
+        </p:txBody>
       </p:sp>
     </p:spTree>
     <p:extLst>
@@ -6782,9 +6764,30 @@
 </file>
 
 <file path=customXml/itemProps1.xml><?xml version="1.0" encoding="utf-8"?>
-<ds:datastoreItem xmlns:ds="http://schemas.openxmlformats.org/officeDocument/2006/customXml" ds:itemID="{2F024FBA-EEFA-42D1-9D92-14B93DCDE664}"/>
+<ds:datastoreItem xmlns:ds="http://schemas.openxmlformats.org/officeDocument/2006/customXml" ds:itemID="{2F024FBA-EEFA-42D1-9D92-14B93DCDE664}">
+  <ds:schemaRefs>
+    <ds:schemaRef ds:uri="http://schemas.microsoft.com/office/2006/metadata/contentType"/>
+    <ds:schemaRef ds:uri="http://schemas.microsoft.com/office/2006/metadata/properties/metaAttributes"/>
+    <ds:schemaRef ds:uri="http://www.w3.org/2001/XMLSchema"/>
+    <ds:schemaRef ds:uri="http://schemas.microsoft.com/office/2006/metadata/properties"/>
+    <ds:schemaRef ds:uri="http://schemas.microsoft.com/sharepoint/v3"/>
+    <ds:schemaRef ds:uri="3d391f55-097d-40f3-a2b2-8dd083b35d41"/>
+    <ds:schemaRef ds:uri="cccaf3ac-2de9-44d4-aa31-54302fceb5f7"/>
+    <ds:schemaRef ds:uri="6e9906aa-e3ac-4ee8-80e3-1cec6a39d65c"/>
+    <ds:schemaRef ds:uri="http://schemas.microsoft.com/office/2006/documentManagement/types"/>
+    <ds:schemaRef ds:uri="http://schemas.microsoft.com/office/infopath/2007/PartnerControls"/>
+    <ds:schemaRef ds:uri="http://schemas.openxmlformats.org/package/2006/metadata/core-properties"/>
+    <ds:schemaRef ds:uri="http://purl.org/dc/elements/1.1/"/>
+    <ds:schemaRef ds:uri="http://purl.org/dc/terms/"/>
+    <ds:schemaRef ds:uri="http://schemas.microsoft.com/internal/obd"/>
+  </ds:schemaRefs>
+</ds:datastoreItem>
 </file>
 
 <file path=customXml/itemProps2.xml><?xml version="1.0" encoding="utf-8"?>
-<ds:datastoreItem xmlns:ds="http://schemas.openxmlformats.org/officeDocument/2006/customXml" ds:itemID="{3F002A55-9C4E-47AD-96DF-99AB54C8C467}"/>
+<ds:datastoreItem xmlns:ds="http://schemas.openxmlformats.org/officeDocument/2006/customXml" ds:itemID="{3F002A55-9C4E-47AD-96DF-99AB54C8C467}">
+  <ds:schemaRefs>
+    <ds:schemaRef ds:uri="http://schemas.microsoft.com/sharepoint/v3/contenttype/forms"/>
+  </ds:schemaRefs>
+</ds:datastoreItem>
 </file>
</xml_diff>